<commit_message>
feat(demo): add 11-slide complete rubric-aligned presentation in light biscuit theme with borderless artifacts
</commit_message>
<xml_diff>
--- a/demo/SevZero_Presentation.pptx
+++ b/demo/SevZero_Presentation.pptx
@@ -15,6 +15,7 @@
     <p:sldId id="263" r:id="rId14"/>
     <p:sldId id="264" r:id="rId15"/>
     <p:sldId id="265" r:id="rId16"/>
+    <p:sldId id="266" r:id="rId17"/>
   </p:sldIdLst>
   <p:sldSz cx="12191695" cy="6858000" type="screen4x3"/>
   <p:notesSz cx="6858000" cy="9144000"/>
@@ -3169,7 +3170,7 @@
                 </a:solidFill>
                 <a:latin typeface="Calibri"/>
               </a:rPr>
-              <a:t>DEVOPS CAPSTONE PROJECT  ·  SESSION 21</a:t>
+              <a:t>DEVOPS ENGINEERING CAPSTONE  ·  SESSION 21</a:t>
             </a:r>
           </a:p>
           <a:p>
@@ -3217,7 +3218,7 @@
                 </a:solidFill>
                 <a:latin typeface="Calibri"/>
               </a:rPr>
-              <a:t>An enterprise cloud-native platform designed to manage critical production outages, on-call coordination, and automated triage across the complete 10-stage DevOps lifecycle.</a:t>
+              <a:t>An enterprise cloud-native platform designed to manage critical production outages, on-call coordination, and automated triage across the complete 10-module DevOps engineering lifecycle.</a:t>
             </a:r>
           </a:p>
           <a:p>
@@ -3407,7 +3408,7 @@
                 </a:solidFill>
                 <a:latin typeface="Calibri"/>
               </a:rPr>
-              <a:t>Slide 1 of 10</a:t>
+              <a:t>Slide 1 of 11</a:t>
             </a:r>
           </a:p>
         </p:txBody>
@@ -3502,7 +3503,7 @@
                 </a:solidFill>
                 <a:latin typeface="Calibri"/>
               </a:rPr>
-              <a:t>MODULE 10 · VERIFICATION</a:t>
+              <a:t>MODULE 9 · OBSERVABILITY</a:t>
             </a:r>
           </a:p>
           <a:p>
@@ -3518,7 +3519,7 @@
                 </a:solidFill>
                 <a:latin typeface="Calibri"/>
               </a:rPr>
-              <a:t>Production Troubleshooting &amp; Module Verification</a:t>
+              <a:t>Prometheus Metrics &amp; Grafana SRE Dashboard</a:t>
             </a:r>
           </a:p>
           <a:p>
@@ -3534,7 +3535,7 @@
                 </a:solidFill>
                 <a:latin typeface="Calibri"/>
               </a:rPr>
-              <a:t>Diagnostic incident triage verified with 23 visual screenshot proofs across all modules</a:t>
+              <a:t>Fulfilling M9 grading criteria: /metrics endpoint, Prometheus scraping (UP), Grafana accessible &amp; live panels</a:t>
             </a:r>
           </a:p>
         </p:txBody>
@@ -3611,7 +3612,7 @@
                 </a:solidFill>
                 <a:latin typeface="Calibri"/>
               </a:rPr>
-              <a:t>•  Scenario 1: ImagePullBackOff Triage
+              <a:t>•  OpenMetrics Telemetry Endpoint
 </a:t>
             </a:r>
             <a:r>
@@ -3621,7 +3622,7 @@
                 </a:solidFill>
                 <a:latin typeface="Calibri"/>
               </a:rPr>
-              <a:t>   Diagnosed missing container registry tag (v999) using kubectl describe pod; resolved by pinning verified SHA digest.</a:t>
+              <a:t>   FastAPI backend exposes structured /metrics scraped every 15s by Prometheus Operator ServiceMonitor.</a:t>
             </a:r>
           </a:p>
           <a:p>
@@ -3637,7 +3638,7 @@
                 </a:solidFill>
                 <a:latin typeface="Calibri"/>
               </a:rPr>
-              <a:t>•  Scenario 2: Empty Endpoints Triage
+              <a:t>•  Active Scraping Verification
 </a:t>
             </a:r>
             <a:r>
@@ -3647,7 +3648,7 @@
                 </a:solidFill>
                 <a:latin typeface="Calibri"/>
               </a:rPr>
-              <a:t>   Diagnosed connection refused error via kubectl get endpoints; resolved by realigning mismatched Service selector labels.</a:t>
+              <a:t>   Prometheus Targets confirms 2/2 backend pod replicas in healthy UP state with zero scrape errors.</a:t>
             </a:r>
           </a:p>
           <a:p>
@@ -3663,7 +3664,7 @@
                 </a:solidFill>
                 <a:latin typeface="Calibri"/>
               </a:rPr>
-              <a:t>•  23 Verifiable Visual Artifacts
+              <a:t>•  SRE 4 Golden Signals Dashboard
 </a:t>
             </a:r>
             <a:r>
@@ -3673,7 +3674,7 @@
                 </a:solidFill>
                 <a:latin typeface="Calibri"/>
               </a:rPr>
-              <a:t>   Every technical milestone backed by high-resolution terminal and dashboard screenshot proofs.</a:t>
+              <a:t>   Grafana 11 dashboard tracking Request Latency (P50/P95/P99), Traffic throughput, Error rate, and Saturation.</a:t>
             </a:r>
           </a:p>
           <a:p>
@@ -3689,7 +3690,7 @@
                 </a:solidFill>
                 <a:latin typeface="Calibri"/>
               </a:rPr>
-              <a:t>•  Comprehensive Milestone Delivery
+              <a:t>•  Demonstrated Reliability SLO
 </a:t>
             </a:r>
             <a:r>
@@ -3699,14 +3700,14 @@
                 </a:solidFill>
                 <a:latin typeface="Calibri"/>
               </a:rPr>
-              <a:t>   Complete implementation of all 10 project modules with reproducible artifacts documented in README.md.</a:t>
+              <a:t>   Maintained P95 latency of 18.4ms (&lt; 50ms SLO) and 0.00% 5xx server error rate across 4,300+ benchmark requests.</a:t>
             </a:r>
           </a:p>
         </p:txBody>
       </p:sp>
       <p:pic>
         <p:nvPicPr>
-          <p:cNvPr id="6" name="Picture 5" descr="18-troubleshoot-broken-service.png"/>
+          <p:cNvPr id="6" name="Picture 5" descr="20-grafana-dashboard.png"/>
           <p:cNvPicPr>
             <a:picLocks noChangeAspect="1"/>
           </p:cNvPicPr>
@@ -3720,8 +3721,8 @@
         </p:blipFill>
         <p:spPr>
           <a:xfrm>
-            <a:off x="6217920" y="3390276"/>
-            <a:ext cx="5059375" cy="1037567"/>
+            <a:off x="6217920" y="2328005"/>
+            <a:ext cx="5059375" cy="3162109"/>
           </a:xfrm>
           <a:prstGeom prst="rect">
             <a:avLst/>
@@ -3761,7 +3762,7 @@
                 </a:solidFill>
                 <a:latin typeface="Calibri"/>
               </a:rPr>
-              <a:t>Artifact: Root Cause Analysis: Service Endpoints Mismatch Triage</a:t>
+              <a:t>Artifact: M9 Deliverable: Grafana 11 Dashboard Monitoring SRE Golden Signals</a:t>
             </a:r>
           </a:p>
         </p:txBody>
@@ -3873,7 +3874,473 @@
                 </a:solidFill>
                 <a:latin typeface="Calibri"/>
               </a:rPr>
-              <a:t>Slide 10 of 10</a:t>
+              <a:t>Slide 10 of 11</a:t>
+            </a:r>
+          </a:p>
+        </p:txBody>
+      </p:sp>
+    </p:spTree>
+  </p:cSld>
+  <p:clrMapOvr>
+    <a:masterClrMapping/>
+  </p:clrMapOvr>
+</p:sld>
+</file>
+
+<file path=ppt/slides/slide11.xml><?xml version="1.0" encoding="utf-8"?>
+<p:sld xmlns:a="http://schemas.openxmlformats.org/drawingml/2006/main" xmlns:p="http://schemas.openxmlformats.org/presentationml/2006/main" xmlns:r="http://schemas.openxmlformats.org/officeDocument/2006/relationships">
+  <p:cSld>
+    <p:spTree>
+      <p:nvGrpSpPr>
+        <p:cNvPr id="1" name=""/>
+        <p:cNvGrpSpPr/>
+        <p:nvPr/>
+      </p:nvGrpSpPr>
+      <p:grpSpPr/>
+      <p:sp>
+        <p:nvSpPr>
+          <p:cNvPr id="2" name="Rectangle 1"/>
+          <p:cNvSpPr/>
+          <p:nvPr/>
+        </p:nvSpPr>
+        <p:spPr>
+          <a:xfrm>
+            <a:off x="0" y="0"/>
+            <a:ext cx="12191695" cy="6858000"/>
+          </a:xfrm>
+          <a:prstGeom prst="rect">
+            <a:avLst/>
+          </a:prstGeom>
+          <a:solidFill>
+            <a:srgbClr val="F5F2EB"/>
+          </a:solidFill>
+          <a:ln>
+            <a:noFill/>
+          </a:ln>
+        </p:spPr>
+        <p:style>
+          <a:lnRef idx="1">
+            <a:schemeClr val="accent1"/>
+          </a:lnRef>
+          <a:fillRef idx="3">
+            <a:schemeClr val="accent1"/>
+          </a:fillRef>
+          <a:effectRef idx="2">
+            <a:schemeClr val="accent1"/>
+          </a:effectRef>
+          <a:fontRef idx="minor">
+            <a:schemeClr val="lt1"/>
+          </a:fontRef>
+        </p:style>
+        <p:txBody>
+          <a:bodyPr rtlCol="0" anchor="ctr"/>
+          <a:lstStyle/>
+          <a:p>
+            <a:pPr algn="ctr"/>
+          </a:p>
+        </p:txBody>
+      </p:sp>
+      <p:sp>
+        <p:nvSpPr>
+          <p:cNvPr id="3" name="TextBox 2"/>
+          <p:cNvSpPr txBox="1"/>
+          <p:nvPr/>
+        </p:nvSpPr>
+        <p:spPr>
+          <a:xfrm>
+            <a:off x="914400" y="594360"/>
+            <a:ext cx="10362895" cy="1188720"/>
+          </a:xfrm>
+          <a:prstGeom prst="rect">
+            <a:avLst/>
+          </a:prstGeom>
+          <a:noFill/>
+        </p:spPr>
+        <p:txBody>
+          <a:bodyPr wrap="square" lIns="0" rIns="0" tIns="0" bIns="0">
+            <a:spAutoFit/>
+          </a:bodyPr>
+          <a:lstStyle/>
+          <a:p>
+            <a:r>
+              <a:rPr sz="1000" b="1">
+                <a:solidFill>
+                  <a:srgbClr val="B45309"/>
+                </a:solidFill>
+                <a:latin typeface="Calibri"/>
+              </a:rPr>
+              <a:t>MODULE 10 · VERIFICATION</a:t>
+            </a:r>
+          </a:p>
+          <a:p>
+            <a:pPr>
+              <a:spcBef>
+                <a:spcPts val="400"/>
+              </a:spcBef>
+            </a:pPr>
+            <a:r>
+              <a:rPr sz="2500" b="1">
+                <a:solidFill>
+                  <a:srgbClr val="1C1917"/>
+                </a:solidFill>
+                <a:latin typeface="Calibri"/>
+              </a:rPr>
+              <a:t>Production Troubleshooting &amp; Live Demo Readiness</a:t>
+            </a:r>
+          </a:p>
+          <a:p>
+            <a:pPr>
+              <a:spcBef>
+                <a:spcPts val="300"/>
+              </a:spcBef>
+            </a:pPr>
+            <a:r>
+              <a:rPr sz="1200">
+                <a:solidFill>
+                  <a:srgbClr val="78716C"/>
+                </a:solidFill>
+                <a:latin typeface="Calibri"/>
+              </a:rPr>
+              <a:t>Fulfilling M10 grading criteria: professional README.md, failure scenario exercises &amp; demo walkthrough</a:t>
+            </a:r>
+          </a:p>
+        </p:txBody>
+      </p:sp>
+      <p:sp>
+        <p:nvSpPr>
+          <p:cNvPr id="4" name="Rectangle 3"/>
+          <p:cNvSpPr/>
+          <p:nvPr/>
+        </p:nvSpPr>
+        <p:spPr>
+          <a:xfrm>
+            <a:off x="914400" y="1874519"/>
+            <a:ext cx="10362895" cy="13716"/>
+          </a:xfrm>
+          <a:prstGeom prst="rect">
+            <a:avLst/>
+          </a:prstGeom>
+          <a:solidFill>
+            <a:srgbClr val="E2DCD1"/>
+          </a:solidFill>
+          <a:ln>
+            <a:noFill/>
+          </a:ln>
+        </p:spPr>
+        <p:style>
+          <a:lnRef idx="1">
+            <a:schemeClr val="accent1"/>
+          </a:lnRef>
+          <a:fillRef idx="3">
+            <a:schemeClr val="accent1"/>
+          </a:fillRef>
+          <a:effectRef idx="2">
+            <a:schemeClr val="accent1"/>
+          </a:effectRef>
+          <a:fontRef idx="minor">
+            <a:schemeClr val="lt1"/>
+          </a:fontRef>
+        </p:style>
+        <p:txBody>
+          <a:bodyPr rtlCol="0" anchor="ctr"/>
+          <a:lstStyle/>
+          <a:p>
+            <a:pPr algn="ctr"/>
+          </a:p>
+        </p:txBody>
+      </p:sp>
+      <p:sp>
+        <p:nvSpPr>
+          <p:cNvPr id="5" name="TextBox 4"/>
+          <p:cNvSpPr txBox="1"/>
+          <p:nvPr/>
+        </p:nvSpPr>
+        <p:spPr>
+          <a:xfrm>
+            <a:off x="914400" y="2103120"/>
+            <a:ext cx="4846320" cy="3931920"/>
+          </a:xfrm>
+          <a:prstGeom prst="rect">
+            <a:avLst/>
+          </a:prstGeom>
+          <a:noFill/>
+        </p:spPr>
+        <p:txBody>
+          <a:bodyPr wrap="square" lIns="0" rIns="0" tIns="0" bIns="0">
+            <a:spAutoFit/>
+          </a:bodyPr>
+          <a:lstStyle/>
+          <a:p>
+            <a:r>
+              <a:rPr sz="1300" b="1">
+                <a:solidFill>
+                  <a:srgbClr val="1C1917"/>
+                </a:solidFill>
+                <a:latin typeface="Calibri"/>
+              </a:rPr>
+              <a:t>•  Scenario 1: ImagePullBackOff Triage
+</a:t>
+            </a:r>
+            <a:r>
+              <a:rPr sz="1100">
+                <a:solidFill>
+                  <a:srgbClr val="44403C"/>
+                </a:solidFill>
+                <a:latin typeface="Calibri"/>
+              </a:rPr>
+              <a:t>   Diagnosed missing container registry tag (v999) using kubectl describe pod; resolved by pinning verified SHA digest.</a:t>
+            </a:r>
+          </a:p>
+          <a:p>
+            <a:pPr>
+              <a:spcBef>
+                <a:spcPts val="1600"/>
+              </a:spcBef>
+            </a:pPr>
+            <a:r>
+              <a:rPr sz="1300" b="1">
+                <a:solidFill>
+                  <a:srgbClr val="1C1917"/>
+                </a:solidFill>
+                <a:latin typeface="Calibri"/>
+              </a:rPr>
+              <a:t>•  Scenario 2: Empty Endpoints Triage
+</a:t>
+            </a:r>
+            <a:r>
+              <a:rPr sz="1100">
+                <a:solidFill>
+                  <a:srgbClr val="44403C"/>
+                </a:solidFill>
+                <a:latin typeface="Calibri"/>
+              </a:rPr>
+              <a:t>   Diagnosed connection refused error via kubectl get endpoints; resolved by realigning mismatched Service selector labels.</a:t>
+            </a:r>
+          </a:p>
+          <a:p>
+            <a:pPr>
+              <a:spcBef>
+                <a:spcPts val="1600"/>
+              </a:spcBef>
+            </a:pPr>
+            <a:r>
+              <a:rPr sz="1300" b="1">
+                <a:solidFill>
+                  <a:srgbClr val="1C1917"/>
+                </a:solidFill>
+                <a:latin typeface="Calibri"/>
+              </a:rPr>
+              <a:t>•  Comprehensive Project Documentation
+</a:t>
+            </a:r>
+            <a:r>
+              <a:rPr sz="1100">
+                <a:solidFill>
+                  <a:srgbClr val="44403C"/>
+                </a:solidFill>
+                <a:latin typeface="Calibri"/>
+              </a:rPr>
+              <a:t>   Complete README.md explaining architecture, quickstart commands, API tables, and verification steps.</a:t>
+            </a:r>
+          </a:p>
+          <a:p>
+            <a:pPr>
+              <a:spcBef>
+                <a:spcPts val="1600"/>
+              </a:spcBef>
+            </a:pPr>
+            <a:r>
+              <a:rPr sz="1300" b="1">
+                <a:solidFill>
+                  <a:srgbClr val="1C1917"/>
+                </a:solidFill>
+                <a:latin typeface="Calibri"/>
+              </a:rPr>
+              <a:t>•  Live Demo Readiness
+</a:t>
+            </a:r>
+            <a:r>
+              <a:rPr sz="1100">
+                <a:solidFill>
+                  <a:srgbClr val="44403C"/>
+                </a:solidFill>
+                <a:latin typeface="Calibri"/>
+              </a:rPr>
+              <a:t>   End-to-end verified delivery workflow: git commit trigger -&gt; CI test &amp; build -&gt; GHCR push -&gt; Helm atomic rolling update.</a:t>
+            </a:r>
+          </a:p>
+        </p:txBody>
+      </p:sp>
+      <p:pic>
+        <p:nvPicPr>
+          <p:cNvPr id="6" name="Picture 5" descr="18-troubleshoot-broken-service.png"/>
+          <p:cNvPicPr>
+            <a:picLocks noChangeAspect="1"/>
+          </p:cNvPicPr>
+          <p:nvPr/>
+        </p:nvPicPr>
+        <p:blipFill>
+          <a:blip r:embed="rId2"/>
+          <a:stretch>
+            <a:fillRect/>
+          </a:stretch>
+        </p:blipFill>
+        <p:spPr>
+          <a:xfrm>
+            <a:off x="6217920" y="3390276"/>
+            <a:ext cx="5059375" cy="1037567"/>
+          </a:xfrm>
+          <a:prstGeom prst="rect">
+            <a:avLst/>
+          </a:prstGeom>
+          <a:ln>
+            <a:noFill/>
+          </a:ln>
+        </p:spPr>
+      </p:pic>
+      <p:sp>
+        <p:nvSpPr>
+          <p:cNvPr id="7" name="TextBox 6"/>
+          <p:cNvSpPr txBox="1"/>
+          <p:nvPr/>
+        </p:nvSpPr>
+        <p:spPr>
+          <a:xfrm>
+            <a:off x="6217920" y="5715000"/>
+            <a:ext cx="5059375" cy="320040"/>
+          </a:xfrm>
+          <a:prstGeom prst="rect">
+            <a:avLst/>
+          </a:prstGeom>
+          <a:noFill/>
+        </p:spPr>
+        <p:txBody>
+          <a:bodyPr wrap="square" lIns="0" rIns="0" tIns="0" bIns="0">
+            <a:spAutoFit/>
+          </a:bodyPr>
+          <a:lstStyle/>
+          <a:p>
+            <a:pPr algn="ctr"/>
+            <a:r>
+              <a:rPr sz="950">
+                <a:solidFill>
+                  <a:srgbClr val="78716C"/>
+                </a:solidFill>
+                <a:latin typeface="Calibri"/>
+              </a:rPr>
+              <a:t>Artifact: M10 Deliverable: Root Cause Analysis on Broken Service Endpoints</a:t>
+            </a:r>
+          </a:p>
+        </p:txBody>
+      </p:sp>
+      <p:sp>
+        <p:nvSpPr>
+          <p:cNvPr id="8" name="Rectangle 7"/>
+          <p:cNvSpPr/>
+          <p:nvPr/>
+        </p:nvSpPr>
+        <p:spPr>
+          <a:xfrm>
+            <a:off x="914400" y="6217920"/>
+            <a:ext cx="10362895" cy="9144"/>
+          </a:xfrm>
+          <a:prstGeom prst="rect">
+            <a:avLst/>
+          </a:prstGeom>
+          <a:solidFill>
+            <a:srgbClr val="E2DCD1"/>
+          </a:solidFill>
+          <a:ln>
+            <a:noFill/>
+          </a:ln>
+        </p:spPr>
+        <p:style>
+          <a:lnRef idx="1">
+            <a:schemeClr val="accent1"/>
+          </a:lnRef>
+          <a:fillRef idx="3">
+            <a:schemeClr val="accent1"/>
+          </a:fillRef>
+          <a:effectRef idx="2">
+            <a:schemeClr val="accent1"/>
+          </a:effectRef>
+          <a:fontRef idx="minor">
+            <a:schemeClr val="lt1"/>
+          </a:fontRef>
+        </p:style>
+        <p:txBody>
+          <a:bodyPr rtlCol="0" anchor="ctr"/>
+          <a:lstStyle/>
+          <a:p>
+            <a:pPr algn="ctr"/>
+          </a:p>
+        </p:txBody>
+      </p:sp>
+      <p:sp>
+        <p:nvSpPr>
+          <p:cNvPr id="9" name="TextBox 8"/>
+          <p:cNvSpPr txBox="1"/>
+          <p:nvPr/>
+        </p:nvSpPr>
+        <p:spPr>
+          <a:xfrm>
+            <a:off x="914400" y="6309360"/>
+            <a:ext cx="7315200" cy="320040"/>
+          </a:xfrm>
+          <a:prstGeom prst="rect">
+            <a:avLst/>
+          </a:prstGeom>
+          <a:noFill/>
+        </p:spPr>
+        <p:txBody>
+          <a:bodyPr wrap="none" lIns="0" rIns="0" tIns="0" bIns="0">
+            <a:spAutoFit/>
+          </a:bodyPr>
+          <a:lstStyle/>
+          <a:p>
+            <a:r>
+              <a:rPr sz="950">
+                <a:solidFill>
+                  <a:srgbClr val="78716C"/>
+                </a:solidFill>
+                <a:latin typeface="Calibri"/>
+              </a:rPr>
+              <a:t>SevZero — Production SRE Incident &amp; Reliability Platform  |  Sathwik Perla (Roll: 590)</a:t>
+            </a:r>
+          </a:p>
+        </p:txBody>
+      </p:sp>
+      <p:sp>
+        <p:nvSpPr>
+          <p:cNvPr id="10" name="TextBox 9"/>
+          <p:cNvSpPr txBox="1"/>
+          <p:nvPr/>
+        </p:nvSpPr>
+        <p:spPr>
+          <a:xfrm>
+            <a:off x="9144000" y="6309360"/>
+            <a:ext cx="2133295" cy="320040"/>
+          </a:xfrm>
+          <a:prstGeom prst="rect">
+            <a:avLst/>
+          </a:prstGeom>
+          <a:noFill/>
+        </p:spPr>
+        <p:txBody>
+          <a:bodyPr wrap="none" lIns="0" rIns="0" tIns="0" bIns="0">
+            <a:spAutoFit/>
+          </a:bodyPr>
+          <a:lstStyle/>
+          <a:p>
+            <a:pPr algn="r"/>
+            <a:r>
+              <a:rPr sz="950" b="1">
+                <a:solidFill>
+                  <a:srgbClr val="78716C"/>
+                </a:solidFill>
+                <a:latin typeface="Calibri"/>
+              </a:rPr>
+              <a:t>Slide 11 of 11</a:t>
             </a:r>
           </a:p>
         </p:txBody>
@@ -3968,7 +4435,7 @@
                 </a:solidFill>
                 <a:latin typeface="Calibri"/>
               </a:rPr>
-              <a:t>MODULE 1 · ARCHITECTURE</a:t>
+              <a:t>MODULE 1 · APPLICATION CORE</a:t>
             </a:r>
           </a:p>
           <a:p>
@@ -3984,7 +4451,7 @@
                 </a:solidFill>
                 <a:latin typeface="Calibri"/>
               </a:rPr>
-              <a:t>SevZero Platform &amp; SRE Incident Purpose</a:t>
+              <a:t>FastAPI Microservice &amp; Relational Data Store</a:t>
             </a:r>
           </a:p>
           <a:p>
@@ -4000,7 +4467,7 @@
                 </a:solidFill>
                 <a:latin typeface="Calibri"/>
               </a:rPr>
-              <a:t>Transitioning from generic task management to mission-critical production outage triage</a:t>
+              <a:t>Fulfilling M1 grading criteria: /health probe, 4+ REST API endpoints, Alembic migrations &amp; React UI</a:t>
             </a:r>
           </a:p>
         </p:txBody>
@@ -4077,7 +4544,7 @@
                 </a:solidFill>
                 <a:latin typeface="Calibri"/>
               </a:rPr>
-              <a:t>•  Sev-0 Incident Paradigm
+              <a:t>•  FastAPI REST Endpoints &amp; Probes
 </a:t>
             </a:r>
             <a:r>
@@ -4087,7 +4554,7 @@
                 </a:solidFill>
                 <a:latin typeface="Calibri"/>
               </a:rPr>
-              <a:t>   Replaces generic to-do apps with a production-grade platform dedicated to Sev-0 and Sev-1 catastrophic incident response.</a:t>
+              <a:t>   Exposes /health (returning UP status), /ready probe, /metrics, and 4+ incident CRUD endpoints for complete on-call lifecycle management.</a:t>
             </a:r>
           </a:p>
           <a:p>
@@ -4103,7 +4570,7 @@
                 </a:solidFill>
                 <a:latin typeface="Calibri"/>
               </a:rPr>
-              <a:t>•  Modern Microservice Stack
+              <a:t>•  Relational Persistence &amp; Alembic
 </a:t>
             </a:r>
             <a:r>
@@ -4113,7 +4580,7 @@
                 </a:solidFill>
                 <a:latin typeface="Calibri"/>
               </a:rPr>
-              <a:t>   FastAPI async REST backend, PostgreSQL 16 relational database with Alembic migrations, and a Vite/React web dashboard.</a:t>
+              <a:t>   PostgreSQL 16 relational backend with schema versioning managed via Alembic (0001_create_incidents migration).</a:t>
             </a:r>
           </a:p>
           <a:p>
@@ -4129,7 +4596,7 @@
                 </a:solidFill>
                 <a:latin typeface="Calibri"/>
               </a:rPr>
-              <a:t>•  Telemetry &amp; Metrics Driven
+              <a:t>•  Responsive React SRE Dashboard
 </a:t>
             </a:r>
             <a:r>
@@ -4139,7 +4606,7 @@
                 </a:solidFill>
                 <a:latin typeface="Calibri"/>
               </a:rPr>
-              <a:t>   Equipped with OpenMetrics endpoints scraping live latency, traffic, and error metrics for automated observability.</a:t>
+              <a:t>   Clean Vite/React single-page application displaying real-time incident severity (Sev-0/Sev-1), resolution workflows, and SLA metrics.</a:t>
             </a:r>
           </a:p>
           <a:p>
@@ -4155,7 +4622,7 @@
                 </a:solidFill>
                 <a:latin typeface="Calibri"/>
               </a:rPr>
-              <a:t>•  Full Lifecycle Alignment
+              <a:t>•  Strict Plagiarism Immunity
 </a:t>
             </a:r>
             <a:r>
@@ -4165,7 +4632,7 @@
                 </a:solidFill>
                 <a:latin typeface="Calibri"/>
               </a:rPr>
-              <a:t>   Engineered from day one for seamless containerization and zero-downtime rolling updates in Kubernetes.</a:t>
+              <a:t>   Built from scratch around SRE site reliability workflows, fully differentiated from the reference TaskBoard project.</a:t>
             </a:r>
           </a:p>
         </p:txBody>
@@ -4227,7 +4694,7 @@
                 </a:solidFill>
                 <a:latin typeface="Calibri"/>
               </a:rPr>
-              <a:t>Artifact: Live SevZero Incident Management Interface (:3000)</a:t>
+              <a:t>Artifact: M1 Deliverable: SevZero Web Application Interface (:3000)</a:t>
             </a:r>
           </a:p>
         </p:txBody>
@@ -4339,7 +4806,7 @@
                 </a:solidFill>
                 <a:latin typeface="Calibri"/>
               </a:rPr>
-              <a:t>Slide 2 of 10</a:t>
+              <a:t>Slide 2 of 11</a:t>
             </a:r>
           </a:p>
         </p:txBody>
@@ -4434,7 +4901,7 @@
                 </a:solidFill>
                 <a:latin typeface="Calibri"/>
               </a:rPr>
-              <a:t>MODULE 2 · QUALITY ASSURANCE</a:t>
+              <a:t>MODULE 2 · TESTING QUALITY</a:t>
             </a:r>
           </a:p>
           <a:p>
@@ -4450,7 +4917,7 @@
                 </a:solidFill>
                 <a:latin typeface="Calibri"/>
               </a:rPr>
-              <a:t>Automated Pytest Testing Suite &amp; CI Gate</a:t>
+              <a:t>Automated Pytest Suite &amp; Regression Gate</a:t>
             </a:r>
           </a:p>
           <a:p>
@@ -4466,7 +4933,7 @@
                 </a:solidFill>
                 <a:latin typeface="Calibri"/>
               </a:rPr>
-              <a:t>Guaranteeing zero regressions before code reaches containerization or deployment</a:t>
+              <a:t>Fulfilling M2 grading criteria: pytest -v clean execution, 5+ test cases, isolated database &amp; pytest.ini</a:t>
             </a:r>
           </a:p>
         </p:txBody>
@@ -4553,7 +5020,7 @@
                 </a:solidFill>
                 <a:latin typeface="Calibri"/>
               </a:rPr>
-              <a:t>   Validates health probes, incident CRUD operations, status state transitions, and error boundary behaviors.</a:t>
+              <a:t>   Exceeds the 5+ test requirement with 12 unit and integration tests covering health probes, CRUD lifecycle, and error boundaries.</a:t>
             </a:r>
           </a:p>
           <a:p>
@@ -4569,7 +5036,7 @@
                 </a:solidFill>
                 <a:latin typeface="Calibri"/>
               </a:rPr>
-              <a:t>•  Isolated SQLite In-Memory Database
+              <a:t>•  Isolated Database via conftest.py
 </a:t>
             </a:r>
             <a:r>
@@ -4579,7 +5046,7 @@
                 </a:solidFill>
                 <a:latin typeface="Calibri"/>
               </a:rPr>
-              <a:t>   Uses an independent SQLite database during testing via conftest.py, guaranteeing zero pollution to production.</a:t>
+              <a:t>   Uses an independent in-memory SQLite database fixture, guaranteeing zero pollution to production PostgreSQL data.</a:t>
             </a:r>
           </a:p>
           <a:p>
@@ -4595,7 +5062,7 @@
                 </a:solidFill>
                 <a:latin typeface="Calibri"/>
               </a:rPr>
-              <a:t>•  Sub-Second Test Execution
+              <a:t>•  Sub-Second Test Execution (0.05s)
 </a:t>
             </a:r>
             <a:r>
@@ -4605,7 +5072,7 @@
                 </a:solidFill>
                 <a:latin typeface="Calibri"/>
               </a:rPr>
-              <a:t>   Entire 12-test suite executes in 0.05 seconds, delivering immediate feedback during local development and CI runs.</a:t>
+              <a:t>   Entire test suite completes in 0.05 seconds, delivering immediate feedback during local development and CI runs.</a:t>
             </a:r>
           </a:p>
           <a:p>
@@ -4621,7 +5088,7 @@
                 </a:solidFill>
                 <a:latin typeface="Calibri"/>
               </a:rPr>
-              <a:t>•  Strict CI Gate Halt
+              <a:t>•  Automated CI Gate Enforcement
 </a:t>
             </a:r>
             <a:r>
@@ -4631,7 +5098,7 @@
                 </a:solidFill>
                 <a:latin typeface="Calibri"/>
               </a:rPr>
-              <a:t>   Pre-configured in pytest.ini; any failing unit or integration test immediately aborts the deployment pipeline.</a:t>
+              <a:t>   Pre-configured in pytest.ini; any regression or test failure immediately aborts the deployment pipeline.</a:t>
             </a:r>
           </a:p>
         </p:txBody>
@@ -4693,7 +5160,7 @@
                 </a:solidFill>
                 <a:latin typeface="Calibri"/>
               </a:rPr>
-              <a:t>Artifact: 12 of 12 Pytest Unit and Integration Tests Passing</a:t>
+              <a:t>Artifact: M2 Deliverable: 12 of 12 Pytest Tests Passing (0.05s)</a:t>
             </a:r>
           </a:p>
         </p:txBody>
@@ -4805,7 +5272,7 @@
                 </a:solidFill>
                 <a:latin typeface="Calibri"/>
               </a:rPr>
-              <a:t>Slide 3 of 10</a:t>
+              <a:t>Slide 3 of 11</a:t>
             </a:r>
           </a:p>
         </p:txBody>
@@ -4900,7 +5367,7 @@
                 </a:solidFill>
                 <a:latin typeface="Calibri"/>
               </a:rPr>
-              <a:t>MODULE 4 · CONTAINERIZATION</a:t>
+              <a:t>MODULE 3 · VERSION CONTROL</a:t>
             </a:r>
           </a:p>
           <a:p>
@@ -4916,7 +5383,7 @@
                 </a:solidFill>
                 <a:latin typeface="Calibri"/>
               </a:rPr>
-              <a:t>Multi-Stage Non-Root Docker Architecture</a:t>
+              <a:t>Git Commit History &amp; Repository Hygiene</a:t>
             </a:r>
           </a:p>
           <a:p>
@@ -4932,7 +5399,7 @@
                 </a:solidFill>
                 <a:latin typeface="Calibri"/>
               </a:rPr>
-              <a:t>Eliminating container escape vulnerabilities through least-privilege security design</a:t>
+              <a:t>Fulfilling M3 grading criteria: 10+ meaningful commits, semantic conventions &amp; clean .gitignore</a:t>
             </a:r>
           </a:p>
         </p:txBody>
@@ -5009,7 +5476,7 @@
                 </a:solidFill>
                 <a:latin typeface="Calibri"/>
               </a:rPr>
-              <a:t>•  Multi-Stage Build Pipeline
+              <a:t>•  15+ Atomic Semantic Commits
 </a:t>
             </a:r>
             <a:r>
@@ -5019,7 +5486,7 @@
                 </a:solidFill>
                 <a:latin typeface="Calibri"/>
               </a:rPr>
-              <a:t>   Stage 1 compiles dependencies with build tooling; Stage 2 extracts only runtime binaries into a lean production image.</a:t>
+              <a:t>   Exceeds the 10-commit requirement with meaningful Conventional Commits (feat, fix, refactor, docs) describing technical changes.</a:t>
             </a:r>
           </a:p>
           <a:p>
@@ -5035,7 +5502,7 @@
                 </a:solidFill>
                 <a:latin typeface="Calibri"/>
               </a:rPr>
-              <a:t>•  Strict Non-Root Execution
+              <a:t>•  Strict Exclusion via .gitignore
 </a:t>
             </a:r>
             <a:r>
@@ -5045,7 +5512,7 @@
                 </a:solidFill>
                 <a:latin typeface="Calibri"/>
               </a:rPr>
-              <a:t>   Backend runs under unprivileged 'appuser' (UID 10001) and frontend runs under unprivileged 'nginx' (UID 101).</a:t>
+              <a:t>   Thorough .gitignore excludes .env files, node_modules, __pycache__, .venv, and terraform state files.</a:t>
             </a:r>
           </a:p>
           <a:p>
@@ -5061,7 +5528,7 @@
                 </a:solidFill>
                 <a:latin typeface="Calibri"/>
               </a:rPr>
-              <a:t>•  Docker Compose Stack
+              <a:t>•  Zero Secrets in Repository
 </a:t>
             </a:r>
             <a:r>
@@ -5071,7 +5538,7 @@
                 </a:solidFill>
                 <a:latin typeface="Calibri"/>
               </a:rPr>
-              <a:t>   Declarative 3-service orchestration linking backend, frontend, and PostgreSQL with automated healthcheck dependency ordering.</a:t>
+              <a:t>   Strict audit verifies zero AWS credentials, access keys, database passwords, or private keys committed to Git history.</a:t>
             </a:r>
           </a:p>
           <a:p>
@@ -5087,7 +5554,7 @@
                 </a:solidFill>
                 <a:latin typeface="Calibri"/>
               </a:rPr>
-              <a:t>•  Minimized Attack Surface
+              <a:t>•  Clean Project Structure
 </a:t>
             </a:r>
             <a:r>
@@ -5097,14 +5564,14 @@
                 </a:solidFill>
                 <a:latin typeface="Calibri"/>
               </a:rPr>
-              <a:t>   Completely removes root shell privileges and package managers from all deployed production containers.</a:t>
+              <a:t>   Organized across modular directories (backend, frontend, helm, terraform, k8s, troubleshooting) for maintainability.</a:t>
             </a:r>
           </a:p>
         </p:txBody>
       </p:sp>
       <p:pic>
         <p:nvPicPr>
-          <p:cNvPr id="6" name="Picture 5" descr="02-docker-compose-up.png"/>
+          <p:cNvPr id="6" name="Picture 5" descr="19-git-commit-history.png"/>
           <p:cNvPicPr>
             <a:picLocks noChangeAspect="1"/>
           </p:cNvPicPr>
@@ -5118,8 +5585,8 @@
         </p:blipFill>
         <p:spPr>
           <a:xfrm>
-            <a:off x="6217920" y="3291460"/>
-            <a:ext cx="5059375" cy="1235198"/>
+            <a:off x="6217920" y="2985131"/>
+            <a:ext cx="5059375" cy="1847857"/>
           </a:xfrm>
           <a:prstGeom prst="rect">
             <a:avLst/>
@@ -5159,7 +5626,7 @@
                 </a:solidFill>
                 <a:latin typeface="Calibri"/>
               </a:rPr>
-              <a:t>Artifact: Healthy 3-Service Docker Compose Local Stack</a:t>
+              <a:t>Artifact: M3 Deliverable: Clean Git Commit History with Conventional Commits</a:t>
             </a:r>
           </a:p>
         </p:txBody>
@@ -5271,7 +5738,7 @@
                 </a:solidFill>
                 <a:latin typeface="Calibri"/>
               </a:rPr>
-              <a:t>Slide 4 of 10</a:t>
+              <a:t>Slide 4 of 11</a:t>
             </a:r>
           </a:p>
         </p:txBody>
@@ -5366,7 +5833,7 @@
                 </a:solidFill>
                 <a:latin typeface="Calibri"/>
               </a:rPr>
-              <a:t>MODULE 5 · CONTINUOUS DELIVERY</a:t>
+              <a:t>MODULE 4 · CONTAINERIZATION</a:t>
             </a:r>
           </a:p>
           <a:p>
@@ -5382,7 +5849,7 @@
                 </a:solidFill>
                 <a:latin typeface="Calibri"/>
               </a:rPr>
-              <a:t>3-Stage Automated GitHub Actions Pipeline</a:t>
+              <a:t>Multi-Stage Non-Root Docker Architecture</a:t>
             </a:r>
           </a:p>
           <a:p>
@@ -5398,7 +5865,7 @@
                 </a:solidFill>
                 <a:latin typeface="Calibri"/>
               </a:rPr>
-              <a:t>Autonomous testing, security scanning, and cluster deployment triggered on every commit</a:t>
+              <a:t>Fulfilling M4 grading criteria: backend Dockerfile, multi-stage frontend, non-root users &amp; Compose stack</a:t>
             </a:r>
           </a:p>
         </p:txBody>
@@ -5475,7 +5942,7 @@
                 </a:solidFill>
                 <a:latin typeface="Calibri"/>
               </a:rPr>
-              <a:t>•  Stage 1: Validate Gate (24s)
+              <a:t>•  Multi-Stage Frontend Build
 </a:t>
             </a:r>
             <a:r>
@@ -5485,7 +5952,7 @@
                 </a:solidFill>
                 <a:latin typeface="Calibri"/>
               </a:rPr>
-              <a:t>   Executes backend pytest suite and frontend npm build, verifying code integrity prior to image builds.</a:t>
+              <a:t>   Stage 1 compiles React assets using Node 22; Stage 2 extracts only static artifacts into a lean unprivileged Nginx image.</a:t>
             </a:r>
           </a:p>
           <a:p>
@@ -5501,7 +5968,7 @@
                 </a:solidFill>
                 <a:latin typeface="Calibri"/>
               </a:rPr>
-              <a:t>•  Stage 2: Build &amp; Scan (1m)
+              <a:t>•  Strict Non-Root User Execution
 </a:t>
             </a:r>
             <a:r>
@@ -5511,7 +5978,7 @@
                 </a:solidFill>
                 <a:latin typeface="Calibri"/>
               </a:rPr>
-              <a:t>   Constructs Docker images, triggers automated Trivy vulnerability scanning, and publishes immutable SHA tags to GHCR.</a:t>
+              <a:t>   Backend runs as unprivileged 'appuser' (UID 10001); frontend runs under unprivileged 'nginx' (UID 101) with zero root privileges.</a:t>
             </a:r>
           </a:p>
           <a:p>
@@ -5527,7 +5994,7 @@
                 </a:solidFill>
                 <a:latin typeface="Calibri"/>
               </a:rPr>
-              <a:t>•  Stage 3: Deploy via Helm (5s)
+              <a:t>•  Single-Command Compose Stack
 </a:t>
             </a:r>
             <a:r>
@@ -5537,7 +6004,7 @@
                 </a:solidFill>
                 <a:latin typeface="Calibri"/>
               </a:rPr>
-              <a:t>   Executes atomic zero-downtime rolling updates in the Kubernetes cluster using Helm 3.</a:t>
+              <a:t>   docker compose up --build launches all three services (backend, frontend, postgres) with automated healthcheck dependencies.</a:t>
             </a:r>
           </a:p>
           <a:p>
@@ -5553,7 +6020,7 @@
                 </a:solidFill>
                 <a:latin typeface="Calibri"/>
               </a:rPr>
-              <a:t>•  Zero Manual Deployments
+              <a:t>•  Minimized Attack Surface
 </a:t>
             </a:r>
             <a:r>
@@ -5563,14 +6030,14 @@
                 </a:solidFill>
                 <a:latin typeface="Calibri"/>
               </a:rPr>
-              <a:t>   Enforces end-to-end continuous delivery with automated audit logging on every commit.</a:t>
+              <a:t>   Eliminates root shell access and unused package compilers from production container images.</a:t>
             </a:r>
           </a:p>
         </p:txBody>
       </p:sp>
       <p:pic>
         <p:nvPicPr>
-          <p:cNvPr id="6" name="Picture 5" descr="21-github-actions-pipeline.png"/>
+          <p:cNvPr id="6" name="Picture 5" descr="02-docker-compose-up.png"/>
           <p:cNvPicPr>
             <a:picLocks noChangeAspect="1"/>
           </p:cNvPicPr>
@@ -5584,8 +6051,8 @@
         </p:blipFill>
         <p:spPr>
           <a:xfrm>
-            <a:off x="6217920" y="2266245"/>
-            <a:ext cx="5059375" cy="3285629"/>
+            <a:off x="6217920" y="3291460"/>
+            <a:ext cx="5059375" cy="1235198"/>
           </a:xfrm>
           <a:prstGeom prst="rect">
             <a:avLst/>
@@ -5625,7 +6092,7 @@
                 </a:solidFill>
                 <a:latin typeface="Calibri"/>
               </a:rPr>
-              <a:t>Artifact: Synchronous 3-Stage GitHub Actions Delivery Pipeline</a:t>
+              <a:t>Artifact: M4 Deliverable: Healthy 3-Service Docker Compose Stack</a:t>
             </a:r>
           </a:p>
         </p:txBody>
@@ -5737,7 +6204,7 @@
                 </a:solidFill>
                 <a:latin typeface="Calibri"/>
               </a:rPr>
-              <a:t>Slide 5 of 10</a:t>
+              <a:t>Slide 5 of 11</a:t>
             </a:r>
           </a:p>
         </p:txBody>
@@ -5832,7 +6299,7 @@
                 </a:solidFill>
                 <a:latin typeface="Calibri"/>
               </a:rPr>
-              <a:t>MODULE 6 · DEVSECOPS</a:t>
+              <a:t>MODULE 5 · CI/CD PIPELINE</a:t>
             </a:r>
           </a:p>
           <a:p>
@@ -5848,7 +6315,7 @@
                 </a:solidFill>
                 <a:latin typeface="Calibri"/>
               </a:rPr>
-              <a:t>Aquasecurity Trivy Container Vulnerability Gating</a:t>
+              <a:t>3-Stage Automated GitHub Actions Delivery</a:t>
             </a:r>
           </a:p>
           <a:p>
@@ -5864,7 +6331,7 @@
                 </a:solidFill>
                 <a:latin typeface="Calibri"/>
               </a:rPr>
-              <a:t>Enforcing strict automated security compliance before container images are published</a:t>
+              <a:t>Fulfilling M5 grading criteria: push to main trigger, pytest gate, frontend build &amp; GHCR SHA tags</a:t>
             </a:r>
           </a:p>
         </p:txBody>
@@ -5941,7 +6408,7 @@
                 </a:solidFill>
                 <a:latin typeface="Calibri"/>
               </a:rPr>
-              <a:t>•  Automated CVE Gating
+              <a:t>•  Stage 1: Validate Gate (24s)
 </a:t>
             </a:r>
             <a:r>
@@ -5951,7 +6418,7 @@
                 </a:solidFill>
                 <a:latin typeface="Calibri"/>
               </a:rPr>
-              <a:t>   Configured with --severity HIGH,CRITICAL and --exit-code 1 to actively reject vulnerable builds.</a:t>
+              <a:t>   Executes backend pytest suite and frontend npm build, verifying code integrity prior to image builds.</a:t>
             </a:r>
           </a:p>
           <a:p>
@@ -5967,7 +6434,7 @@
                 </a:solidFill>
                 <a:latin typeface="Calibri"/>
               </a:rPr>
-              <a:t>•  Vulnerability Identification
+              <a:t>•  Stage 2: Build &amp; Scan (1m)
 </a:t>
             </a:r>
             <a:r>
@@ -5977,7 +6444,7 @@
                 </a:solidFill>
                 <a:latin typeface="Calibri"/>
               </a:rPr>
-              <a:t>   Detected CVE-2025-62727 (Starlette HTTP Range DoS flaw) during backend scan with documented patch path.</a:t>
+              <a:t>   Constructs Docker images, triggers automated Trivy vulnerability scanning, and publishes images to GHCR.</a:t>
             </a:r>
           </a:p>
           <a:p>
@@ -5993,7 +6460,7 @@
                 </a:solidFill>
                 <a:latin typeface="Calibri"/>
               </a:rPr>
-              <a:t>•  Clean Frontend Verification
+              <a:t>•  Immutable Git SHA Image Tags
 </a:t>
             </a:r>
             <a:r>
@@ -6003,7 +6470,7 @@
                 </a:solidFill>
                 <a:latin typeface="Calibri"/>
               </a:rPr>
-              <a:t>   Frontend Alpine container verified with zero HIGH and zero CRITICAL security vulnerabilities.</a:t>
+              <a:t>   Container images are strictly tagged with the exact 7-character commit SHA (never generic 'latest' tags).</a:t>
             </a:r>
           </a:p>
           <a:p>
@@ -6019,7 +6486,7 @@
                 </a:solidFill>
                 <a:latin typeface="Calibri"/>
               </a:rPr>
-              <a:t>•  Continuous Security Posture
+              <a:t>•  Stage 3: Atomic Helm Deploy (5s)
 </a:t>
             </a:r>
             <a:r>
@@ -6029,14 +6496,14 @@
                 </a:solidFill>
                 <a:latin typeface="Calibri"/>
               </a:rPr>
-              <a:t>   Prevents vulnerable container images from ever reaching the production artifact registry.</a:t>
+              <a:t>   Executes automated zero-downtime rolling update via Helm 3 upon successful completion of prior stages.</a:t>
             </a:r>
           </a:p>
         </p:txBody>
       </p:sp>
       <p:pic>
         <p:nvPicPr>
-          <p:cNvPr id="6" name="Picture 5" descr="04-trivy-scan-backend.png"/>
+          <p:cNvPr id="6" name="Picture 5" descr="21-github-actions-pipeline.png"/>
           <p:cNvPicPr>
             <a:picLocks noChangeAspect="1"/>
           </p:cNvPicPr>
@@ -6050,8 +6517,8 @@
         </p:blipFill>
         <p:spPr>
           <a:xfrm>
-            <a:off x="6217920" y="3143236"/>
-            <a:ext cx="5059375" cy="1531646"/>
+            <a:off x="6217920" y="2266245"/>
+            <a:ext cx="5059375" cy="3285629"/>
           </a:xfrm>
           <a:prstGeom prst="rect">
             <a:avLst/>
@@ -6091,7 +6558,7 @@
                 </a:solidFill>
                 <a:latin typeface="Calibri"/>
               </a:rPr>
-              <a:t>Artifact: Trivy CVE Security Scan &amp; Vulnerability Detection Output</a:t>
+              <a:t>Artifact: M5 Deliverable: 3-Stage Synchronous GitHub Actions Pipeline</a:t>
             </a:r>
           </a:p>
         </p:txBody>
@@ -6203,7 +6670,7 @@
                 </a:solidFill>
                 <a:latin typeface="Calibri"/>
               </a:rPr>
-              <a:t>Slide 6 of 10</a:t>
+              <a:t>Slide 6 of 11</a:t>
             </a:r>
           </a:p>
         </p:txBody>
@@ -6298,7 +6765,7 @@
                 </a:solidFill>
                 <a:latin typeface="Calibri"/>
               </a:rPr>
-              <a:t>MODULE 7 · CLOUD FOUNDATION</a:t>
+              <a:t>MODULE 6 · DEVSECOPS</a:t>
             </a:r>
           </a:p>
           <a:p>
@@ -6314,7 +6781,7 @@
                 </a:solidFill>
                 <a:latin typeface="Calibri"/>
               </a:rPr>
-              <a:t>AWS VPC &amp; Managed EKS Infrastructure via Terraform</a:t>
+              <a:t>Aquasecurity Trivy Container Vulnerability Gating</a:t>
             </a:r>
           </a:p>
           <a:p>
@@ -6330,7 +6797,7 @@
                 </a:solidFill>
                 <a:latin typeface="Calibri"/>
               </a:rPr>
-              <a:t>Declarative Infrastructure as Code ensuring reproducible and auditable cloud environments</a:t>
+              <a:t>Fulfilling M6 grading criteria: Trivy CI scan, fail on HIGH/CRITICAL, and written explanation of CVE</a:t>
             </a:r>
           </a:p>
         </p:txBody>
@@ -6407,7 +6874,7 @@
                 </a:solidFill>
                 <a:latin typeface="Calibri"/>
               </a:rPr>
-              <a:t>•  Multi-AZ VPC Architecture
+              <a:t>•  Automated CI Security Gate
 </a:t>
             </a:r>
             <a:r>
@@ -6417,7 +6884,7 @@
                 </a:solidFill>
                 <a:latin typeface="Calibri"/>
               </a:rPr>
-              <a:t>   Provisions a robust 10.20.0.0/16 VPC across two availability zones (ap-south-1a and ap-south-1b).</a:t>
+              <a:t>   Trivy scan executes in CI on both backend and frontend images with --severity HIGH,CRITICAL and --exit-code 1.</a:t>
             </a:r>
           </a:p>
           <a:p>
@@ -6433,7 +6900,7 @@
                 </a:solidFill>
                 <a:latin typeface="Calibri"/>
               </a:rPr>
-              <a:t>•  Public &amp; Private Subnet Tiering
+              <a:t>•  Detected CVE Explanation
 </a:t>
             </a:r>
             <a:r>
@@ -6443,7 +6910,7 @@
                 </a:solidFill>
                 <a:latin typeface="Calibri"/>
               </a:rPr>
-              <a:t>   Isolates EKS worker nodes in private subnets, while load balancers and NAT gateways reside in public subnets.</a:t>
+              <a:t>   Identified CVE-2025-62727 (Starlette HTTP Range header DoS flaw) in backend image; documented upstream patch release path.</a:t>
             </a:r>
           </a:p>
           <a:p>
@@ -6459,7 +6926,7 @@
                 </a:solidFill>
                 <a:latin typeface="Calibri"/>
               </a:rPr>
-              <a:t>•  Modular Architecture
+              <a:t>•  Clean Frontend Verification
 </a:t>
             </a:r>
             <a:r>
@@ -6469,7 +6936,7 @@
                 </a:solidFill>
                 <a:latin typeface="Calibri"/>
               </a:rPr>
-              <a:t>   Structured across clean modules (VPC, EKS, Node Groups) with parameterized input variables and output contracts.</a:t>
+              <a:t>   Frontend Alpine container verified with zero HIGH and zero CRITICAL security vulnerabilities.</a:t>
             </a:r>
           </a:p>
           <a:p>
@@ -6485,7 +6952,7 @@
                 </a:solidFill>
                 <a:latin typeface="Calibri"/>
               </a:rPr>
-              <a:t>•  Verified Code Integrity
+              <a:t>•  Automated Policy Enforcement
 </a:t>
             </a:r>
             <a:r>
@@ -6495,14 +6962,14 @@
                 </a:solidFill>
                 <a:latin typeface="Calibri"/>
               </a:rPr>
-              <a:t>   Validated via terraform init and terraform validate with zero syntax or provider configuration errors.</a:t>
+              <a:t>   Guarantees that untracked or vulnerable container images can never reach the production registry.</a:t>
             </a:r>
           </a:p>
         </p:txBody>
       </p:sp>
       <p:pic>
         <p:nvPicPr>
-          <p:cNvPr id="6" name="Picture 5" descr="07-terraform-validate.png"/>
+          <p:cNvPr id="6" name="Picture 5" descr="04-trivy-scan-backend.png"/>
           <p:cNvPicPr>
             <a:picLocks noChangeAspect="1"/>
           </p:cNvPicPr>
@@ -6516,8 +6983,8 @@
         </p:blipFill>
         <p:spPr>
           <a:xfrm>
-            <a:off x="6217920" y="3414980"/>
-            <a:ext cx="5059375" cy="988159"/>
+            <a:off x="6217920" y="3143236"/>
+            <a:ext cx="5059375" cy="1531646"/>
           </a:xfrm>
           <a:prstGeom prst="rect">
             <a:avLst/>
@@ -6557,7 +7024,7 @@
                 </a:solidFill>
                 <a:latin typeface="Calibri"/>
               </a:rPr>
-              <a:t>Artifact: Terraform Validate: Configuration Successfully Verified</a:t>
+              <a:t>Artifact: M6 Deliverable: Trivy Security Scan &amp; Vulnerability Detection Output</a:t>
             </a:r>
           </a:p>
         </p:txBody>
@@ -6669,7 +7136,7 @@
                 </a:solidFill>
                 <a:latin typeface="Calibri"/>
               </a:rPr>
-              <a:t>Slide 7 of 10</a:t>
+              <a:t>Slide 7 of 11</a:t>
             </a:r>
           </a:p>
         </p:txBody>
@@ -6764,7 +7231,7 @@
                 </a:solidFill>
                 <a:latin typeface="Calibri"/>
               </a:rPr>
-              <a:t>MODULE 8 · ORCHESTRATION</a:t>
+              <a:t>MODULE 7 · INFRASTRUCTURE AS CODE</a:t>
             </a:r>
           </a:p>
           <a:p>
@@ -6780,7 +7247,7 @@
                 </a:solidFill>
                 <a:latin typeface="Calibri"/>
               </a:rPr>
-              <a:t>Kubernetes Clustering, Ingress &amp; Autoscaling</a:t>
+              <a:t>AWS VPC &amp; Managed EKS Infrastructure via Terraform</a:t>
             </a:r>
           </a:p>
           <a:p>
@@ -6796,7 +7263,7 @@
                 </a:solidFill>
                 <a:latin typeface="Calibri"/>
               </a:rPr>
-              <a:t>Enterprise container orchestration with declarative Helm 3 package management</a:t>
+              <a:t>Fulfilling M7 grading criteria: valid HCL, terraform init/validate pass, VPC with 2 public subnets, EKS &amp; tfvars.example</a:t>
             </a:r>
           </a:p>
         </p:txBody>
@@ -6873,7 +7340,7 @@
                 </a:solidFill>
                 <a:latin typeface="Calibri"/>
               </a:rPr>
-              <a:t>•  Helm 3 Chart Packaging
+              <a:t>•  Multi-AZ VPC Architecture
 </a:t>
             </a:r>
             <a:r>
@@ -6883,7 +7350,7 @@
                 </a:solidFill>
                 <a:latin typeface="Calibri"/>
               </a:rPr>
-              <a:t>   Custom chart in helm/sevzero/ packaging backend, frontend, postgres, ingress, and horizontal pod autoscaler.</a:t>
+              <a:t>   Provisions a robust 10.20.0.0/16 VPC across two availability zones (ap-south-1a and ap-south-1b) with public &amp; private subnets.</a:t>
             </a:r>
           </a:p>
           <a:p>
@@ -6899,7 +7366,7 @@
                 </a:solidFill>
                 <a:latin typeface="Calibri"/>
               </a:rPr>
-              <a:t>•  Namespace Isolation
+              <a:t>•  EKS Managed Node Groups
 </a:t>
             </a:r>
             <a:r>
@@ -6909,7 +7376,7 @@
                 </a:solidFill>
                 <a:latin typeface="Calibri"/>
               </a:rPr>
-              <a:t>   All microservices run inside the dedicated 'sevzero' namespace with isolated RBAC and service accounts.</a:t>
+              <a:t>   Provisions an AWS Kubernetes 1.31 control plane with t3.medium managed worker nodes isolated in private subnets.</a:t>
             </a:r>
           </a:p>
           <a:p>
@@ -6925,7 +7392,7 @@
                 </a:solidFill>
                 <a:latin typeface="Calibri"/>
               </a:rPr>
-              <a:t>•  Ingress Host Routing
+              <a:t>•  Modular Architecture
 </a:t>
             </a:r>
             <a:r>
@@ -6935,7 +7402,7 @@
                 </a:solidFill>
                 <a:latin typeface="Calibri"/>
               </a:rPr>
-              <a:t>   Directs traffic via Nginx Ingress Controller under host 'sevzero.local', cleanly routing '/' to UI and '/api' to backend.</a:t>
+              <a:t>   Structured across clean modules (VPC, EKS, Node Groups) with parameterized input variables and output contracts.</a:t>
             </a:r>
           </a:p>
           <a:p>
@@ -6951,7 +7418,7 @@
                 </a:solidFill>
                 <a:latin typeface="Calibri"/>
               </a:rPr>
-              <a:t>•  Dynamic HPA Autoscaling
+              <a:t>•  Validated &amp; Secrets-Free
 </a:t>
             </a:r>
             <a:r>
@@ -6961,14 +7428,14 @@
                 </a:solidFill>
                 <a:latin typeface="Calibri"/>
               </a:rPr>
-              <a:t>   Horizontal Pod Autoscaler dynamically scales backend from 2 to 6 replicas when CPU exceeds 75% utilization.</a:t>
+              <a:t>   Verified via terraform init and terraform validate (0 errors); includes terraform.tfvars.example with zero committed secrets.</a:t>
             </a:r>
           </a:p>
         </p:txBody>
       </p:sp>
       <p:pic>
         <p:nvPicPr>
-          <p:cNvPr id="6" name="Picture 5" descr="11-kubectl-get-pods.png"/>
+          <p:cNvPr id="6" name="Picture 5" descr="07-terraform-validate.png"/>
           <p:cNvPicPr>
             <a:picLocks noChangeAspect="1"/>
           </p:cNvPicPr>
@@ -6982,8 +7449,8 @@
         </p:blipFill>
         <p:spPr>
           <a:xfrm>
-            <a:off x="6217920" y="3242052"/>
-            <a:ext cx="5059375" cy="1334014"/>
+            <a:off x="6217920" y="3414980"/>
+            <a:ext cx="5059375" cy="988159"/>
           </a:xfrm>
           <a:prstGeom prst="rect">
             <a:avLst/>
@@ -7023,7 +7490,7 @@
                 </a:solidFill>
                 <a:latin typeface="Calibri"/>
               </a:rPr>
-              <a:t>Artifact: Kubernetes Pods Running Healthy in 'sevzero' Namespace</a:t>
+              <a:t>Artifact: M7 Deliverable: Terraform Configuration Validated (0 Errors)</a:t>
             </a:r>
           </a:p>
         </p:txBody>
@@ -7135,7 +7602,7 @@
                 </a:solidFill>
                 <a:latin typeface="Calibri"/>
               </a:rPr>
-              <a:t>Slide 8 of 10</a:t>
+              <a:t>Slide 8 of 11</a:t>
             </a:r>
           </a:p>
         </p:txBody>
@@ -7230,7 +7697,7 @@
                 </a:solidFill>
                 <a:latin typeface="Calibri"/>
               </a:rPr>
-              <a:t>MODULE 9 · SRE TELEMETRY</a:t>
+              <a:t>MODULE 8 · ORCHESTRATION</a:t>
             </a:r>
           </a:p>
           <a:p>
@@ -7246,7 +7713,7 @@
                 </a:solidFill>
                 <a:latin typeface="Calibri"/>
               </a:rPr>
-              <a:t>Prometheus Metrics &amp; Grafana SRE Dashboard</a:t>
+              <a:t>Kubernetes Clustering, Ingress &amp; Autoscaling</a:t>
             </a:r>
           </a:p>
           <a:p>
@@ -7262,7 +7729,7 @@
                 </a:solidFill>
                 <a:latin typeface="Calibri"/>
               </a:rPr>
-              <a:t>Real-time monitoring of SRE 4 Golden Signals and service level reliability objectives</a:t>
+              <a:t>Fulfilling M8 grading criteria: namespace.yaml, Helm chart, 2+ replicas each, ClusterIP, Ingress &amp; Running pods</a:t>
             </a:r>
           </a:p>
         </p:txBody>
@@ -7339,7 +7806,7 @@
                 </a:solidFill>
                 <a:latin typeface="Calibri"/>
               </a:rPr>
-              <a:t>•  OpenMetrics Telemetry
+              <a:t>•  Declarative Helm 3 Chart
 </a:t>
             </a:r>
             <a:r>
@@ -7349,7 +7816,7 @@
                 </a:solidFill>
                 <a:latin typeface="Calibri"/>
               </a:rPr>
-              <a:t>   FastAPI microservice exposes structured /metrics scraped every 15s by Prometheus Operator ServiceMonitor.</a:t>
+              <a:t>   Custom chart in helm/sevzero/ parameterizing backend, frontend, postgres, ingress, and horizontal pod autoscaler.</a:t>
             </a:r>
           </a:p>
           <a:p>
@@ -7365,7 +7832,7 @@
                 </a:solidFill>
                 <a:latin typeface="Calibri"/>
               </a:rPr>
-              <a:t>•  SRE 4 Golden Signals
+              <a:t>•  Namespace Isolation
 </a:t>
             </a:r>
             <a:r>
@@ -7375,7 +7842,7 @@
                 </a:solidFill>
                 <a:latin typeface="Calibri"/>
               </a:rPr>
-              <a:t>   Comprehensive dashboard monitoring Request Latency (P50/P95/P99), Traffic throughput, Error rates, and Saturation.</a:t>
+              <a:t>   All microservices run inside the dedicated 'sevzero' namespace with isolated RBAC and service accounts.</a:t>
             </a:r>
           </a:p>
           <a:p>
@@ -7391,7 +7858,7 @@
                 </a:solidFill>
                 <a:latin typeface="Calibri"/>
               </a:rPr>
-              <a:t>•  Strict Latency SLO
+              <a:t>•  High Availability &amp; Autoscaling
 </a:t>
             </a:r>
             <a:r>
@@ -7401,7 +7868,7 @@
                 </a:solidFill>
                 <a:latin typeface="Calibri"/>
               </a:rPr>
-              <a:t>   Demonstrated P95 latency of 18.4ms, comfortably satisfying the &lt; 50ms production reliability objective.</a:t>
+              <a:t>   Backend and frontend configured with 2+ replicas each; HPA dynamically autoscales backend (2 to 6 pods) at 75% CPU.</a:t>
             </a:r>
           </a:p>
           <a:p>
@@ -7417,7 +7884,7 @@
                 </a:solidFill>
                 <a:latin typeface="Calibri"/>
               </a:rPr>
-              <a:t>•  Zero Error Rate Tracked
+              <a:t>•  Ingress Host Routing
 </a:t>
             </a:r>
             <a:r>
@@ -7427,14 +7894,14 @@
                 </a:solidFill>
                 <a:latin typeface="Calibri"/>
               </a:rPr>
-              <a:t>   Maintained 0.00% 5xx server-side error rate across 4,300+ continuous benchmark requests.</a:t>
+              <a:t>   Nginx Ingress routes host 'sevzero.local', cleanly routing '/' to the React UI and '/api' to the FastAPI backend.</a:t>
             </a:r>
           </a:p>
         </p:txBody>
       </p:sp>
       <p:pic>
         <p:nvPicPr>
-          <p:cNvPr id="6" name="Picture 5" descr="20-grafana-dashboard.png"/>
+          <p:cNvPr id="6" name="Picture 5" descr="11-kubectl-get-pods.png"/>
           <p:cNvPicPr>
             <a:picLocks noChangeAspect="1"/>
           </p:cNvPicPr>
@@ -7448,8 +7915,8 @@
         </p:blipFill>
         <p:spPr>
           <a:xfrm>
-            <a:off x="6217920" y="2328005"/>
-            <a:ext cx="5059375" cy="3162109"/>
+            <a:off x="6217920" y="3242052"/>
+            <a:ext cx="5059375" cy="1334014"/>
           </a:xfrm>
           <a:prstGeom prst="rect">
             <a:avLst/>
@@ -7489,7 +7956,7 @@
                 </a:solidFill>
                 <a:latin typeface="Calibri"/>
               </a:rPr>
-              <a:t>Artifact: Grafana 11 Dashboard: SRE Golden Signals &amp; Telemetry</a:t>
+              <a:t>Artifact: M8 Deliverable: Kubernetes Pods in Running State in 'sevzero' Namespace</a:t>
             </a:r>
           </a:p>
         </p:txBody>
@@ -7601,7 +8068,7 @@
                 </a:solidFill>
                 <a:latin typeface="Calibri"/>
               </a:rPr>
-              <a:t>Slide 9 of 10</a:t>
+              <a:t>Slide 9 of 11</a:t>
             </a:r>
           </a:p>
         </p:txBody>

</xml_diff>